<commit_message>
Organize telemetry data into weighted edge CSV and clean JSON file
</commit_message>
<xml_diff>
--- a/IDP_Phase1_Presentation.pptx
+++ b/IDP_Phase1_Presentation.pptx
@@ -5,16 +5,16 @@
     <p:sldMasterId id="2147483648" r:id="rId1"/>
   </p:sldMasterIdLst>
   <p:sldIdLst>
-    <p:sldId id="256" r:id="rId7"/>
-    <p:sldId id="257" r:id="rId8"/>
-    <p:sldId id="258" r:id="rId9"/>
-    <p:sldId id="259" r:id="rId10"/>
-    <p:sldId id="260" r:id="rId11"/>
-    <p:sldId id="261" r:id="rId12"/>
-    <p:sldId id="262" r:id="rId13"/>
-    <p:sldId id="263" r:id="rId14"/>
+    <p:sldId id="256" r:id="rId2"/>
+    <p:sldId id="257" r:id="rId3"/>
+    <p:sldId id="258" r:id="rId4"/>
+    <p:sldId id="259" r:id="rId5"/>
+    <p:sldId id="260" r:id="rId6"/>
+    <p:sldId id="261" r:id="rId7"/>
+    <p:sldId id="262" r:id="rId8"/>
+    <p:sldId id="263" r:id="rId9"/>
   </p:sldIdLst>
-  <p:sldSz cx="12191695" cy="6858000" type="screen4x3"/>
+  <p:sldSz cx="12192000" cy="6858000"/>
   <p:notesSz cx="6858000" cy="9144000"/>
   <p:defaultTextStyle>
     <a:defPPr>
@@ -111,7 +111,52 @@
       </a:defRPr>
     </a:lvl9pPr>
   </p:defaultTextStyle>
+  <p:extLst>
+    <p:ext uri="{EFAFB233-063F-42B5-8137-9DF3F51BA10A}">
+      <p15:sldGuideLst xmlns:p15="http://schemas.microsoft.com/office/powerpoint/2012/main">
+        <p15:guide id="1" orient="horz" pos="2160">
+          <p15:clr>
+            <a:srgbClr val="A4A3A4"/>
+          </p15:clr>
+        </p15:guide>
+        <p15:guide id="2" pos="2880">
+          <p15:clr>
+            <a:srgbClr val="A4A3A4"/>
+          </p15:clr>
+        </p15:guide>
+      </p15:sldGuideLst>
+    </p:ext>
+  </p:extLst>
 </p:presentation>
+</file>
+
+<file path=ppt/changesInfos/changesInfo1.xml><?xml version="1.0" encoding="utf-8"?>
+<pc:chgInfo xmlns:a="http://schemas.openxmlformats.org/drawingml/2006/main" xmlns:r="http://schemas.openxmlformats.org/officeDocument/2006/relationships" xmlns:ac="http://schemas.microsoft.com/office/drawing/2013/main/command" xmlns:pc="http://schemas.microsoft.com/office/powerpoint/2013/main/command">
+  <pc:docChgLst>
+    <pc:chgData name="Swastik Mishra" userId="5d89eda882970810" providerId="LiveId" clId="{EE497EE4-DEFD-4DE7-A979-D84DEF1B4A2F}"/>
+    <pc:docChg chg="custSel modSld">
+      <pc:chgData name="Swastik Mishra" userId="5d89eda882970810" providerId="LiveId" clId="{EE497EE4-DEFD-4DE7-A979-D84DEF1B4A2F}" dt="2026-09-22T16:09:20.884" v="103" actId="20577"/>
+      <pc:docMkLst>
+        <pc:docMk/>
+      </pc:docMkLst>
+      <pc:sldChg chg="modSp mod">
+        <pc:chgData name="Swastik Mishra" userId="5d89eda882970810" providerId="LiveId" clId="{EE497EE4-DEFD-4DE7-A979-D84DEF1B4A2F}" dt="2026-09-22T16:09:20.884" v="103" actId="20577"/>
+        <pc:sldMkLst>
+          <pc:docMk/>
+          <pc:sldMk cId="0" sldId="256"/>
+        </pc:sldMkLst>
+        <pc:spChg chg="mod">
+          <ac:chgData name="Swastik Mishra" userId="5d89eda882970810" providerId="LiveId" clId="{EE497EE4-DEFD-4DE7-A979-D84DEF1B4A2F}" dt="2026-09-22T16:09:20.884" v="103" actId="20577"/>
+          <ac:spMkLst>
+            <pc:docMk/>
+            <pc:sldMk cId="0" sldId="256"/>
+            <ac:spMk id="5" creationId="{00000000-0000-0000-0000-000000000000}"/>
+          </ac:spMkLst>
+        </pc:spChg>
+      </pc:sldChg>
+    </pc:docChg>
+  </pc:docChgLst>
+</pc:chgInfo>
 </file>
 
 <file path=ppt/slideLayouts/slideLayout1.xml><?xml version="1.0" encoding="utf-8"?>
@@ -152,10 +197,9 @@
           <a:lstStyle/>
           <a:p>
             <a:r>
-              <a:rPr lang="en-US" smtClean="0"/>
+              <a:rPr lang="en-US"/>
               <a:t>Click to edit Master title style</a:t>
             </a:r>
-            <a:endParaRPr lang="en-US"/>
           </a:p>
         </p:txBody>
       </p:sp>
@@ -271,10 +315,9 @@
           </a:lstStyle>
           <a:p>
             <a:r>
-              <a:rPr lang="en-US" smtClean="0"/>
+              <a:rPr lang="en-US"/>
               <a:t>Click to edit Master subtitle style</a:t>
             </a:r>
-            <a:endParaRPr lang="en-US"/>
           </a:p>
         </p:txBody>
       </p:sp>
@@ -295,7 +338,7 @@
           <a:p>
             <a:fld id="{5BCAD085-E8A6-8845-BD4E-CB4CCA059FC4}" type="datetimeFigureOut">
               <a:rPr lang="en-US" smtClean="0"/>
-              <a:t>1/27/13</a:t>
+              <a:t>9/22/2026</a:t>
             </a:fld>
             <a:endParaRPr lang="en-US"/>
           </a:p>
@@ -389,10 +432,9 @@
           <a:lstStyle/>
           <a:p>
             <a:r>
-              <a:rPr lang="en-US" smtClean="0"/>
+              <a:rPr lang="en-US"/>
               <a:t>Click to edit Master title style</a:t>
             </a:r>
-            <a:endParaRPr lang="en-US"/>
           </a:p>
         </p:txBody>
       </p:sp>
@@ -413,38 +455,37 @@
           <a:p>
             <a:pPr lvl="0"/>
             <a:r>
-              <a:rPr lang="en-US" smtClean="0"/>
+              <a:rPr lang="en-US"/>
               <a:t>Click to edit Master text styles</a:t>
             </a:r>
           </a:p>
           <a:p>
             <a:pPr lvl="1"/>
             <a:r>
-              <a:rPr lang="en-US" smtClean="0"/>
+              <a:rPr lang="en-US"/>
               <a:t>Second level</a:t>
             </a:r>
           </a:p>
           <a:p>
             <a:pPr lvl="2"/>
             <a:r>
-              <a:rPr lang="en-US" smtClean="0"/>
+              <a:rPr lang="en-US"/>
               <a:t>Third level</a:t>
             </a:r>
           </a:p>
           <a:p>
             <a:pPr lvl="3"/>
             <a:r>
-              <a:rPr lang="en-US" smtClean="0"/>
+              <a:rPr lang="en-US"/>
               <a:t>Fourth level</a:t>
             </a:r>
           </a:p>
           <a:p>
             <a:pPr lvl="4"/>
             <a:r>
-              <a:rPr lang="en-US" smtClean="0"/>
+              <a:rPr lang="en-US"/>
               <a:t>Fifth level</a:t>
             </a:r>
-            <a:endParaRPr lang="en-US"/>
           </a:p>
         </p:txBody>
       </p:sp>
@@ -465,7 +506,7 @@
           <a:p>
             <a:fld id="{5BCAD085-E8A6-8845-BD4E-CB4CCA059FC4}" type="datetimeFigureOut">
               <a:rPr lang="en-US" smtClean="0"/>
-              <a:t>1/27/13</a:t>
+              <a:t>9/22/2026</a:t>
             </a:fld>
             <a:endParaRPr lang="en-US"/>
           </a:p>
@@ -564,10 +605,9 @@
           <a:lstStyle/>
           <a:p>
             <a:r>
-              <a:rPr lang="en-US" smtClean="0"/>
+              <a:rPr lang="en-US"/>
               <a:t>Click to edit Master title style</a:t>
             </a:r>
-            <a:endParaRPr lang="en-US"/>
           </a:p>
         </p:txBody>
       </p:sp>
@@ -593,38 +633,37 @@
           <a:p>
             <a:pPr lvl="0"/>
             <a:r>
-              <a:rPr lang="en-US" smtClean="0"/>
+              <a:rPr lang="en-US"/>
               <a:t>Click to edit Master text styles</a:t>
             </a:r>
           </a:p>
           <a:p>
             <a:pPr lvl="1"/>
             <a:r>
-              <a:rPr lang="en-US" smtClean="0"/>
+              <a:rPr lang="en-US"/>
               <a:t>Second level</a:t>
             </a:r>
           </a:p>
           <a:p>
             <a:pPr lvl="2"/>
             <a:r>
-              <a:rPr lang="en-US" smtClean="0"/>
+              <a:rPr lang="en-US"/>
               <a:t>Third level</a:t>
             </a:r>
           </a:p>
           <a:p>
             <a:pPr lvl="3"/>
             <a:r>
-              <a:rPr lang="en-US" smtClean="0"/>
+              <a:rPr lang="en-US"/>
               <a:t>Fourth level</a:t>
             </a:r>
           </a:p>
           <a:p>
             <a:pPr lvl="4"/>
             <a:r>
-              <a:rPr lang="en-US" smtClean="0"/>
+              <a:rPr lang="en-US"/>
               <a:t>Fifth level</a:t>
             </a:r>
-            <a:endParaRPr lang="en-US"/>
           </a:p>
         </p:txBody>
       </p:sp>
@@ -645,7 +684,7 @@
           <a:p>
             <a:fld id="{5BCAD085-E8A6-8845-BD4E-CB4CCA059FC4}" type="datetimeFigureOut">
               <a:rPr lang="en-US" smtClean="0"/>
-              <a:t>1/27/13</a:t>
+              <a:t>9/22/2026</a:t>
             </a:fld>
             <a:endParaRPr lang="en-US"/>
           </a:p>
@@ -739,10 +778,9 @@
           <a:lstStyle/>
           <a:p>
             <a:r>
-              <a:rPr lang="en-US" smtClean="0"/>
+              <a:rPr lang="en-US"/>
               <a:t>Click to edit Master title style</a:t>
             </a:r>
-            <a:endParaRPr lang="en-US"/>
           </a:p>
         </p:txBody>
       </p:sp>
@@ -763,38 +801,37 @@
           <a:p>
             <a:pPr lvl="0"/>
             <a:r>
-              <a:rPr lang="en-US" smtClean="0"/>
+              <a:rPr lang="en-US"/>
               <a:t>Click to edit Master text styles</a:t>
             </a:r>
           </a:p>
           <a:p>
             <a:pPr lvl="1"/>
             <a:r>
-              <a:rPr lang="en-US" smtClean="0"/>
+              <a:rPr lang="en-US"/>
               <a:t>Second level</a:t>
             </a:r>
           </a:p>
           <a:p>
             <a:pPr lvl="2"/>
             <a:r>
-              <a:rPr lang="en-US" smtClean="0"/>
+              <a:rPr lang="en-US"/>
               <a:t>Third level</a:t>
             </a:r>
           </a:p>
           <a:p>
             <a:pPr lvl="3"/>
             <a:r>
-              <a:rPr lang="en-US" smtClean="0"/>
+              <a:rPr lang="en-US"/>
               <a:t>Fourth level</a:t>
             </a:r>
           </a:p>
           <a:p>
             <a:pPr lvl="4"/>
             <a:r>
-              <a:rPr lang="en-US" smtClean="0"/>
+              <a:rPr lang="en-US"/>
               <a:t>Fifth level</a:t>
             </a:r>
-            <a:endParaRPr lang="en-US"/>
           </a:p>
         </p:txBody>
       </p:sp>
@@ -815,7 +852,7 @@
           <a:p>
             <a:fld id="{5BCAD085-E8A6-8845-BD4E-CB4CCA059FC4}" type="datetimeFigureOut">
               <a:rPr lang="en-US" smtClean="0"/>
-              <a:t>1/27/13</a:t>
+              <a:t>9/22/2026</a:t>
             </a:fld>
             <a:endParaRPr lang="en-US"/>
           </a:p>
@@ -918,10 +955,9 @@
           </a:lstStyle>
           <a:p>
             <a:r>
-              <a:rPr lang="en-US" smtClean="0"/>
+              <a:rPr lang="en-US"/>
               <a:t>Click to edit Master title style</a:t>
             </a:r>
-            <a:endParaRPr lang="en-US"/>
           </a:p>
         </p:txBody>
       </p:sp>
@@ -1038,7 +1074,7 @@
           <a:p>
             <a:pPr lvl="0"/>
             <a:r>
-              <a:rPr lang="en-US" smtClean="0"/>
+              <a:rPr lang="en-US"/>
               <a:t>Click to edit Master text styles</a:t>
             </a:r>
           </a:p>
@@ -1061,7 +1097,7 @@
           <a:p>
             <a:fld id="{5BCAD085-E8A6-8845-BD4E-CB4CCA059FC4}" type="datetimeFigureOut">
               <a:rPr lang="en-US" smtClean="0"/>
-              <a:t>1/27/13</a:t>
+              <a:t>9/22/2026</a:t>
             </a:fld>
             <a:endParaRPr lang="en-US"/>
           </a:p>
@@ -1155,10 +1191,9 @@
           <a:lstStyle/>
           <a:p>
             <a:r>
-              <a:rPr lang="en-US" smtClean="0"/>
+              <a:rPr lang="en-US"/>
               <a:t>Click to edit Master title style</a:t>
             </a:r>
-            <a:endParaRPr lang="en-US"/>
           </a:p>
         </p:txBody>
       </p:sp>
@@ -1212,38 +1247,37 @@
           <a:p>
             <a:pPr lvl="0"/>
             <a:r>
-              <a:rPr lang="en-US" smtClean="0"/>
+              <a:rPr lang="en-US"/>
               <a:t>Click to edit Master text styles</a:t>
             </a:r>
           </a:p>
           <a:p>
             <a:pPr lvl="1"/>
             <a:r>
-              <a:rPr lang="en-US" smtClean="0"/>
+              <a:rPr lang="en-US"/>
               <a:t>Second level</a:t>
             </a:r>
           </a:p>
           <a:p>
             <a:pPr lvl="2"/>
             <a:r>
-              <a:rPr lang="en-US" smtClean="0"/>
+              <a:rPr lang="en-US"/>
               <a:t>Third level</a:t>
             </a:r>
           </a:p>
           <a:p>
             <a:pPr lvl="3"/>
             <a:r>
-              <a:rPr lang="en-US" smtClean="0"/>
+              <a:rPr lang="en-US"/>
               <a:t>Fourth level</a:t>
             </a:r>
           </a:p>
           <a:p>
             <a:pPr lvl="4"/>
             <a:r>
-              <a:rPr lang="en-US" smtClean="0"/>
+              <a:rPr lang="en-US"/>
               <a:t>Fifth level</a:t>
             </a:r>
-            <a:endParaRPr lang="en-US"/>
           </a:p>
         </p:txBody>
       </p:sp>
@@ -1297,38 +1331,37 @@
           <a:p>
             <a:pPr lvl="0"/>
             <a:r>
-              <a:rPr lang="en-US" smtClean="0"/>
+              <a:rPr lang="en-US"/>
               <a:t>Click to edit Master text styles</a:t>
             </a:r>
           </a:p>
           <a:p>
             <a:pPr lvl="1"/>
             <a:r>
-              <a:rPr lang="en-US" smtClean="0"/>
+              <a:rPr lang="en-US"/>
               <a:t>Second level</a:t>
             </a:r>
           </a:p>
           <a:p>
             <a:pPr lvl="2"/>
             <a:r>
-              <a:rPr lang="en-US" smtClean="0"/>
+              <a:rPr lang="en-US"/>
               <a:t>Third level</a:t>
             </a:r>
           </a:p>
           <a:p>
             <a:pPr lvl="3"/>
             <a:r>
-              <a:rPr lang="en-US" smtClean="0"/>
+              <a:rPr lang="en-US"/>
               <a:t>Fourth level</a:t>
             </a:r>
           </a:p>
           <a:p>
             <a:pPr lvl="4"/>
             <a:r>
-              <a:rPr lang="en-US" smtClean="0"/>
+              <a:rPr lang="en-US"/>
               <a:t>Fifth level</a:t>
             </a:r>
-            <a:endParaRPr lang="en-US"/>
           </a:p>
         </p:txBody>
       </p:sp>
@@ -1349,7 +1382,7 @@
           <a:p>
             <a:fld id="{5BCAD085-E8A6-8845-BD4E-CB4CCA059FC4}" type="datetimeFigureOut">
               <a:rPr lang="en-US" smtClean="0"/>
-              <a:t>1/27/13</a:t>
+              <a:t>9/22/2026</a:t>
             </a:fld>
             <a:endParaRPr lang="en-US"/>
           </a:p>
@@ -1447,10 +1480,9 @@
           </a:lstStyle>
           <a:p>
             <a:r>
-              <a:rPr lang="en-US" smtClean="0"/>
+              <a:rPr lang="en-US"/>
               <a:t>Click to edit Master title style</a:t>
             </a:r>
-            <a:endParaRPr lang="en-US"/>
           </a:p>
         </p:txBody>
       </p:sp>
@@ -1513,7 +1545,7 @@
           <a:p>
             <a:pPr lvl="0"/>
             <a:r>
-              <a:rPr lang="en-US" smtClean="0"/>
+              <a:rPr lang="en-US"/>
               <a:t>Click to edit Master text styles</a:t>
             </a:r>
           </a:p>
@@ -1569,38 +1601,37 @@
           <a:p>
             <a:pPr lvl="0"/>
             <a:r>
-              <a:rPr lang="en-US" smtClean="0"/>
+              <a:rPr lang="en-US"/>
               <a:t>Click to edit Master text styles</a:t>
             </a:r>
           </a:p>
           <a:p>
             <a:pPr lvl="1"/>
             <a:r>
-              <a:rPr lang="en-US" smtClean="0"/>
+              <a:rPr lang="en-US"/>
               <a:t>Second level</a:t>
             </a:r>
           </a:p>
           <a:p>
             <a:pPr lvl="2"/>
             <a:r>
-              <a:rPr lang="en-US" smtClean="0"/>
+              <a:rPr lang="en-US"/>
               <a:t>Third level</a:t>
             </a:r>
           </a:p>
           <a:p>
             <a:pPr lvl="3"/>
             <a:r>
-              <a:rPr lang="en-US" smtClean="0"/>
+              <a:rPr lang="en-US"/>
               <a:t>Fourth level</a:t>
             </a:r>
           </a:p>
           <a:p>
             <a:pPr lvl="4"/>
             <a:r>
-              <a:rPr lang="en-US" smtClean="0"/>
+              <a:rPr lang="en-US"/>
               <a:t>Fifth level</a:t>
             </a:r>
-            <a:endParaRPr lang="en-US"/>
           </a:p>
         </p:txBody>
       </p:sp>
@@ -1663,7 +1694,7 @@
           <a:p>
             <a:pPr lvl="0"/>
             <a:r>
-              <a:rPr lang="en-US" smtClean="0"/>
+              <a:rPr lang="en-US"/>
               <a:t>Click to edit Master text styles</a:t>
             </a:r>
           </a:p>
@@ -1719,38 +1750,37 @@
           <a:p>
             <a:pPr lvl="0"/>
             <a:r>
-              <a:rPr lang="en-US" smtClean="0"/>
+              <a:rPr lang="en-US"/>
               <a:t>Click to edit Master text styles</a:t>
             </a:r>
           </a:p>
           <a:p>
             <a:pPr lvl="1"/>
             <a:r>
-              <a:rPr lang="en-US" smtClean="0"/>
+              <a:rPr lang="en-US"/>
               <a:t>Second level</a:t>
             </a:r>
           </a:p>
           <a:p>
             <a:pPr lvl="2"/>
             <a:r>
-              <a:rPr lang="en-US" smtClean="0"/>
+              <a:rPr lang="en-US"/>
               <a:t>Third level</a:t>
             </a:r>
           </a:p>
           <a:p>
             <a:pPr lvl="3"/>
             <a:r>
-              <a:rPr lang="en-US" smtClean="0"/>
+              <a:rPr lang="en-US"/>
               <a:t>Fourth level</a:t>
             </a:r>
           </a:p>
           <a:p>
             <a:pPr lvl="4"/>
             <a:r>
-              <a:rPr lang="en-US" smtClean="0"/>
+              <a:rPr lang="en-US"/>
               <a:t>Fifth level</a:t>
             </a:r>
-            <a:endParaRPr lang="en-US"/>
           </a:p>
         </p:txBody>
       </p:sp>
@@ -1771,7 +1801,7 @@
           <a:p>
             <a:fld id="{5BCAD085-E8A6-8845-BD4E-CB4CCA059FC4}" type="datetimeFigureOut">
               <a:rPr lang="en-US" smtClean="0"/>
-              <a:t>1/27/13</a:t>
+              <a:t>9/22/2026</a:t>
             </a:fld>
             <a:endParaRPr lang="en-US"/>
           </a:p>
@@ -1865,10 +1895,9 @@
           <a:lstStyle/>
           <a:p>
             <a:r>
-              <a:rPr lang="en-US" smtClean="0"/>
+              <a:rPr lang="en-US"/>
               <a:t>Click to edit Master title style</a:t>
             </a:r>
-            <a:endParaRPr lang="en-US"/>
           </a:p>
         </p:txBody>
       </p:sp>
@@ -1889,7 +1918,7 @@
           <a:p>
             <a:fld id="{5BCAD085-E8A6-8845-BD4E-CB4CCA059FC4}" type="datetimeFigureOut">
               <a:rPr lang="en-US" smtClean="0"/>
-              <a:t>1/27/13</a:t>
+              <a:t>9/22/2026</a:t>
             </a:fld>
             <a:endParaRPr lang="en-US"/>
           </a:p>
@@ -1984,7 +2013,7 @@
           <a:p>
             <a:fld id="{5BCAD085-E8A6-8845-BD4E-CB4CCA059FC4}" type="datetimeFigureOut">
               <a:rPr lang="en-US" smtClean="0"/>
-              <a:t>1/27/13</a:t>
+              <a:t>9/22/2026</a:t>
             </a:fld>
             <a:endParaRPr lang="en-US"/>
           </a:p>
@@ -2087,10 +2116,9 @@
           </a:lstStyle>
           <a:p>
             <a:r>
-              <a:rPr lang="en-US" smtClean="0"/>
+              <a:rPr lang="en-US"/>
               <a:t>Click to edit Master title style</a:t>
             </a:r>
-            <a:endParaRPr lang="en-US"/>
           </a:p>
         </p:txBody>
       </p:sp>
@@ -2144,38 +2172,37 @@
           <a:p>
             <a:pPr lvl="0"/>
             <a:r>
-              <a:rPr lang="en-US" smtClean="0"/>
+              <a:rPr lang="en-US"/>
               <a:t>Click to edit Master text styles</a:t>
             </a:r>
           </a:p>
           <a:p>
             <a:pPr lvl="1"/>
             <a:r>
-              <a:rPr lang="en-US" smtClean="0"/>
+              <a:rPr lang="en-US"/>
               <a:t>Second level</a:t>
             </a:r>
           </a:p>
           <a:p>
             <a:pPr lvl="2"/>
             <a:r>
-              <a:rPr lang="en-US" smtClean="0"/>
+              <a:rPr lang="en-US"/>
               <a:t>Third level</a:t>
             </a:r>
           </a:p>
           <a:p>
             <a:pPr lvl="3"/>
             <a:r>
-              <a:rPr lang="en-US" smtClean="0"/>
+              <a:rPr lang="en-US"/>
               <a:t>Fourth level</a:t>
             </a:r>
           </a:p>
           <a:p>
             <a:pPr lvl="4"/>
             <a:r>
-              <a:rPr lang="en-US" smtClean="0"/>
+              <a:rPr lang="en-US"/>
               <a:t>Fifth level</a:t>
             </a:r>
-            <a:endParaRPr lang="en-US"/>
           </a:p>
         </p:txBody>
       </p:sp>
@@ -2238,7 +2265,7 @@
           <a:p>
             <a:pPr lvl="0"/>
             <a:r>
-              <a:rPr lang="en-US" smtClean="0"/>
+              <a:rPr lang="en-US"/>
               <a:t>Click to edit Master text styles</a:t>
             </a:r>
           </a:p>
@@ -2261,7 +2288,7 @@
           <a:p>
             <a:fld id="{5BCAD085-E8A6-8845-BD4E-CB4CCA059FC4}" type="datetimeFigureOut">
               <a:rPr lang="en-US" smtClean="0"/>
-              <a:t>1/27/13</a:t>
+              <a:t>9/22/2026</a:t>
             </a:fld>
             <a:endParaRPr lang="en-US"/>
           </a:p>
@@ -2364,10 +2391,9 @@
           </a:lstStyle>
           <a:p>
             <a:r>
-              <a:rPr lang="en-US" smtClean="0"/>
+              <a:rPr lang="en-US"/>
               <a:t>Click to edit Master title style</a:t>
             </a:r>
-            <a:endParaRPr lang="en-US"/>
           </a:p>
         </p:txBody>
       </p:sp>
@@ -2491,7 +2517,7 @@
           <a:p>
             <a:pPr lvl="0"/>
             <a:r>
-              <a:rPr lang="en-US" smtClean="0"/>
+              <a:rPr lang="en-US"/>
               <a:t>Click to edit Master text styles</a:t>
             </a:r>
           </a:p>
@@ -2514,7 +2540,7 @@
           <a:p>
             <a:fld id="{5BCAD085-E8A6-8845-BD4E-CB4CCA059FC4}" type="datetimeFigureOut">
               <a:rPr lang="en-US" smtClean="0"/>
-              <a:t>1/27/13</a:t>
+              <a:t>9/22/2026</a:t>
             </a:fld>
             <a:endParaRPr lang="en-US"/>
           </a:p>
@@ -2623,10 +2649,9 @@
           <a:lstStyle/>
           <a:p>
             <a:r>
-              <a:rPr lang="en-US" smtClean="0"/>
+              <a:rPr lang="en-US"/>
               <a:t>Click to edit Master title style</a:t>
             </a:r>
-            <a:endParaRPr lang="en-US"/>
           </a:p>
         </p:txBody>
       </p:sp>
@@ -2657,38 +2682,37 @@
           <a:p>
             <a:pPr lvl="0"/>
             <a:r>
-              <a:rPr lang="en-US" smtClean="0"/>
+              <a:rPr lang="en-US"/>
               <a:t>Click to edit Master text styles</a:t>
             </a:r>
           </a:p>
           <a:p>
             <a:pPr lvl="1"/>
             <a:r>
-              <a:rPr lang="en-US" smtClean="0"/>
+              <a:rPr lang="en-US"/>
               <a:t>Second level</a:t>
             </a:r>
           </a:p>
           <a:p>
             <a:pPr lvl="2"/>
             <a:r>
-              <a:rPr lang="en-US" smtClean="0"/>
+              <a:rPr lang="en-US"/>
               <a:t>Third level</a:t>
             </a:r>
           </a:p>
           <a:p>
             <a:pPr lvl="3"/>
             <a:r>
-              <a:rPr lang="en-US" smtClean="0"/>
+              <a:rPr lang="en-US"/>
               <a:t>Fourth level</a:t>
             </a:r>
           </a:p>
           <a:p>
             <a:pPr lvl="4"/>
             <a:r>
-              <a:rPr lang="en-US" smtClean="0"/>
+              <a:rPr lang="en-US"/>
               <a:t>Fifth level</a:t>
             </a:r>
-            <a:endParaRPr lang="en-US"/>
           </a:p>
         </p:txBody>
       </p:sp>
@@ -2727,7 +2751,7 @@
           <a:p>
             <a:fld id="{5BCAD085-E8A6-8845-BD4E-CB4CCA059FC4}" type="datetimeFigureOut">
               <a:rPr lang="en-US" smtClean="0"/>
-              <a:t>1/27/13</a:t>
+              <a:t>9/22/2026</a:t>
             </a:fld>
             <a:endParaRPr lang="en-US"/>
           </a:p>
@@ -3086,7 +3110,7 @@
 </file>
 
 <file path=ppt/slides/slide1.xml><?xml version="1.0" encoding="utf-8"?>
-<p:sld xmlns:a="http://schemas.openxmlformats.org/drawingml/2006/main" xmlns:p="http://schemas.openxmlformats.org/presentationml/2006/main" xmlns:r="http://schemas.openxmlformats.org/officeDocument/2006/relationships">
+<p:sld xmlns:a="http://schemas.openxmlformats.org/drawingml/2006/main" xmlns:r="http://schemas.openxmlformats.org/officeDocument/2006/relationships" xmlns:p="http://schemas.openxmlformats.org/presentationml/2006/main">
   <p:cSld>
     <p:spTree>
       <p:nvGrpSpPr>
@@ -3094,7 +3118,14 @@
         <p:cNvGrpSpPr/>
         <p:nvPr/>
       </p:nvGrpSpPr>
-      <p:grpSpPr/>
+      <p:grpSpPr>
+        <a:xfrm>
+          <a:off x="0" y="0"/>
+          <a:ext cx="0" cy="0"/>
+          <a:chOff x="0" y="0"/>
+          <a:chExt cx="0" cy="0"/>
+        </a:xfrm>
+      </p:grpSpPr>
       <p:sp>
         <p:nvSpPr>
           <p:cNvPr id="2" name="Rectangle 1"/>
@@ -3137,6 +3168,7 @@
           <a:lstStyle/>
           <a:p>
             <a:pPr algn="ctr"/>
+            <a:endParaRPr/>
           </a:p>
         </p:txBody>
       </p:sp>
@@ -3182,6 +3214,7 @@
           <a:lstStyle/>
           <a:p>
             <a:pPr algn="ctr"/>
+            <a:endParaRPr/>
           </a:p>
         </p:txBody>
       </p:sp>
@@ -3292,7 +3325,7 @@
           </a:fontRef>
         </p:style>
         <p:txBody>
-          <a:bodyPr rtlCol="0" anchor="ctr" wrap="square"/>
+          <a:bodyPr wrap="square" rtlCol="0" anchor="ctr"/>
           <a:lstStyle/>
           <a:p>
             <a:pPr algn="ctr">
@@ -3306,6 +3339,7 @@
               </a:defRPr>
             </a:pPr>
             <a:r>
+              <a:rPr dirty="0"/>
               <a:t>STUDENT CREDENTIALS</a:t>
             </a:r>
           </a:p>
@@ -3318,16 +3352,59 @@
               </a:defRPr>
             </a:pPr>
             <a:r>
-              <a:t>Name: Swastik Mishra</a:t>
-            </a:r>
-            <a:br/>
-            <a:r>
-              <a:t>Registration No: 23BCE10436</a:t>
-            </a:r>
-            <a:br/>
-            <a:r>
-              <a:t>Semester: 3rd Semester | IDP - Phase 1 Review</a:t>
-            </a:r>
+              <a:rPr dirty="0"/>
+              <a:t>Swastik Mishra</a:t>
+            </a:r>
+            <a:r>
+              <a:rPr lang="en-US" dirty="0"/>
+              <a:t>-25BYB1054</a:t>
+            </a:r>
+          </a:p>
+          <a:p>
+            <a:pPr>
+              <a:defRPr sz="1250">
+                <a:solidFill>
+                  <a:srgbClr val="FFFFFF"/>
+                </a:solidFill>
+              </a:defRPr>
+            </a:pPr>
+            <a:r>
+              <a:rPr lang="en-US" dirty="0"/>
+              <a:t>Rajesh B 25BYB</a:t>
+            </a:r>
+          </a:p>
+          <a:p>
+            <a:pPr>
+              <a:defRPr sz="1250">
+                <a:solidFill>
+                  <a:srgbClr val="FFFFFF"/>
+                </a:solidFill>
+              </a:defRPr>
+            </a:pPr>
+            <a:r>
+              <a:rPr lang="en-US"/>
+              <a:t>Sanidhya Sharma-25BYB1114</a:t>
+            </a:r>
+            <a:br>
+              <a:rPr dirty="0"/>
+            </a:br>
+            <a:r>
+              <a:rPr dirty="0"/>
+              <a:t>Semester: 3rd Semester | IDP </a:t>
+            </a:r>
+            <a:r>
+              <a:rPr lang="en-IN" dirty="0"/>
+              <a:t>–</a:t>
+            </a:r>
+            <a:r>
+              <a:rPr dirty="0"/>
+              <a:t> Review</a:t>
+            </a:r>
+            <a:r>
+              <a:rPr lang="en-US" dirty="0"/>
+              <a:t>-2</a:t>
+            </a:r>
+            <a:endParaRPr dirty="0"/>
           </a:p>
         </p:txBody>
       </p:sp>
@@ -3369,7 +3446,7 @@
           </a:fontRef>
         </p:style>
         <p:txBody>
-          <a:bodyPr rtlCol="0" anchor="ctr" wrap="square"/>
+          <a:bodyPr wrap="square" rtlCol="0" anchor="ctr"/>
           <a:lstStyle/>
           <a:p>
             <a:pPr algn="ctr">
@@ -3417,7 +3494,7 @@
 </file>
 
 <file path=ppt/slides/slide2.xml><?xml version="1.0" encoding="utf-8"?>
-<p:sld xmlns:a="http://schemas.openxmlformats.org/drawingml/2006/main" xmlns:p="http://schemas.openxmlformats.org/presentationml/2006/main" xmlns:r="http://schemas.openxmlformats.org/officeDocument/2006/relationships">
+<p:sld xmlns:a="http://schemas.openxmlformats.org/drawingml/2006/main" xmlns:r="http://schemas.openxmlformats.org/officeDocument/2006/relationships" xmlns:p="http://schemas.openxmlformats.org/presentationml/2006/main">
   <p:cSld>
     <p:spTree>
       <p:nvGrpSpPr>
@@ -3425,7 +3502,14 @@
         <p:cNvGrpSpPr/>
         <p:nvPr/>
       </p:nvGrpSpPr>
-      <p:grpSpPr/>
+      <p:grpSpPr>
+        <a:xfrm>
+          <a:off x="0" y="0"/>
+          <a:ext cx="0" cy="0"/>
+          <a:chOff x="0" y="0"/>
+          <a:chExt cx="0" cy="0"/>
+        </a:xfrm>
+      </p:grpSpPr>
       <p:sp>
         <p:nvSpPr>
           <p:cNvPr id="2" name="TextBox 1"/>
@@ -3443,7 +3527,7 @@
           <a:noFill/>
         </p:spPr>
         <p:txBody>
-          <a:bodyPr wrap="square" lIns="0" rIns="0" tIns="0" bIns="0">
+          <a:bodyPr wrap="square" lIns="0" tIns="0" rIns="0" bIns="0">
             <a:spAutoFit/>
           </a:bodyPr>
           <a:lstStyle/>
@@ -3479,7 +3563,7 @@
           <a:noFill/>
         </p:spPr>
         <p:txBody>
-          <a:bodyPr wrap="square" lIns="0" rIns="0" tIns="0" bIns="0">
+          <a:bodyPr wrap="square" lIns="0" tIns="0" rIns="0" bIns="0">
             <a:spAutoFit/>
           </a:bodyPr>
           <a:lstStyle/>
@@ -3540,6 +3624,7 @@
           <a:lstStyle/>
           <a:p>
             <a:pPr algn="ctr"/>
+            <a:endParaRPr/>
           </a:p>
         </p:txBody>
       </p:sp>
@@ -3581,7 +3666,7 @@
           </a:fontRef>
         </p:style>
         <p:txBody>
-          <a:bodyPr rtlCol="0" anchor="ctr" wrap="square" lIns="274320" tIns="182880"/>
+          <a:bodyPr wrap="square" lIns="274320" tIns="182880" rtlCol="0" anchor="ctr"/>
           <a:lstStyle/>
           <a:p>
             <a:pPr algn="ctr">
@@ -3650,7 +3735,7 @@
           </a:fontRef>
         </p:style>
         <p:txBody>
-          <a:bodyPr rtlCol="0" anchor="ctr" wrap="square" lIns="274320" tIns="182880"/>
+          <a:bodyPr wrap="square" lIns="274320" tIns="182880" rtlCol="0" anchor="ctr"/>
           <a:lstStyle/>
           <a:p>
             <a:pPr algn="ctr">
@@ -3719,7 +3804,7 @@
           </a:fontRef>
         </p:style>
         <p:txBody>
-          <a:bodyPr rtlCol="0" anchor="ctr" wrap="square" lIns="274320" tIns="182880"/>
+          <a:bodyPr wrap="square" lIns="274320" tIns="182880" rtlCol="0" anchor="ctr"/>
           <a:lstStyle/>
           <a:p>
             <a:pPr algn="ctr">
@@ -3788,7 +3873,7 @@
           </a:fontRef>
         </p:style>
         <p:txBody>
-          <a:bodyPr rtlCol="0" anchor="ctr" wrap="square" lIns="274320" tIns="182880"/>
+          <a:bodyPr wrap="square" lIns="274320" tIns="182880" rtlCol="0" anchor="ctr"/>
           <a:lstStyle/>
           <a:p>
             <a:pPr algn="ctr">
@@ -3857,7 +3942,7 @@
           </a:fontRef>
         </p:style>
         <p:txBody>
-          <a:bodyPr rtlCol="0" anchor="ctr" wrap="square" lIns="274320" tIns="182880"/>
+          <a:bodyPr wrap="square" lIns="274320" tIns="182880" rtlCol="0" anchor="ctr"/>
           <a:lstStyle/>
           <a:p>
             <a:pPr algn="ctr">
@@ -3926,7 +4011,7 @@
           </a:fontRef>
         </p:style>
         <p:txBody>
-          <a:bodyPr rtlCol="0" anchor="ctr" wrap="square" lIns="274320" tIns="182880"/>
+          <a:bodyPr wrap="square" lIns="274320" tIns="182880" rtlCol="0" anchor="ctr"/>
           <a:lstStyle/>
           <a:p>
             <a:pPr algn="ctr">
@@ -3966,7 +4051,7 @@
 </file>
 
 <file path=ppt/slides/slide3.xml><?xml version="1.0" encoding="utf-8"?>
-<p:sld xmlns:a="http://schemas.openxmlformats.org/drawingml/2006/main" xmlns:p="http://schemas.openxmlformats.org/presentationml/2006/main" xmlns:r="http://schemas.openxmlformats.org/officeDocument/2006/relationships">
+<p:sld xmlns:a="http://schemas.openxmlformats.org/drawingml/2006/main" xmlns:r="http://schemas.openxmlformats.org/officeDocument/2006/relationships" xmlns:p="http://schemas.openxmlformats.org/presentationml/2006/main">
   <p:cSld>
     <p:spTree>
       <p:nvGrpSpPr>
@@ -3974,7 +4059,14 @@
         <p:cNvGrpSpPr/>
         <p:nvPr/>
       </p:nvGrpSpPr>
-      <p:grpSpPr/>
+      <p:grpSpPr>
+        <a:xfrm>
+          <a:off x="0" y="0"/>
+          <a:ext cx="0" cy="0"/>
+          <a:chOff x="0" y="0"/>
+          <a:chExt cx="0" cy="0"/>
+        </a:xfrm>
+      </p:grpSpPr>
       <p:sp>
         <p:nvSpPr>
           <p:cNvPr id="2" name="TextBox 1"/>
@@ -3992,7 +4084,7 @@
           <a:noFill/>
         </p:spPr>
         <p:txBody>
-          <a:bodyPr wrap="square" lIns="0" rIns="0" tIns="0" bIns="0">
+          <a:bodyPr wrap="square" lIns="0" tIns="0" rIns="0" bIns="0">
             <a:spAutoFit/>
           </a:bodyPr>
           <a:lstStyle/>
@@ -4028,7 +4120,7 @@
           <a:noFill/>
         </p:spPr>
         <p:txBody>
-          <a:bodyPr wrap="square" lIns="0" rIns="0" tIns="0" bIns="0">
+          <a:bodyPr wrap="square" lIns="0" tIns="0" rIns="0" bIns="0">
             <a:spAutoFit/>
           </a:bodyPr>
           <a:lstStyle/>
@@ -4089,6 +4181,7 @@
           <a:lstStyle/>
           <a:p>
             <a:pPr algn="ctr"/>
+            <a:endParaRPr/>
           </a:p>
         </p:txBody>
       </p:sp>
@@ -4130,7 +4223,7 @@
           </a:fontRef>
         </p:style>
         <p:txBody>
-          <a:bodyPr rtlCol="0" anchor="ctr" wrap="square" lIns="274320" rIns="274320" tIns="274320"/>
+          <a:bodyPr wrap="square" lIns="274320" tIns="274320" rIns="274320" rtlCol="0" anchor="ctr"/>
           <a:lstStyle/>
           <a:p>
             <a:pPr algn="ctr">
@@ -4295,7 +4388,7 @@
           </a:fontRef>
         </p:style>
         <p:txBody>
-          <a:bodyPr rtlCol="0" anchor="ctr" wrap="square" lIns="274320" rIns="274320" tIns="274320"/>
+          <a:bodyPr wrap="square" lIns="274320" tIns="274320" rIns="274320" rtlCol="0" anchor="ctr"/>
           <a:lstStyle/>
           <a:p>
             <a:pPr algn="ctr">
@@ -4431,7 +4524,7 @@
 </file>
 
 <file path=ppt/slides/slide4.xml><?xml version="1.0" encoding="utf-8"?>
-<p:sld xmlns:a="http://schemas.openxmlformats.org/drawingml/2006/main" xmlns:p="http://schemas.openxmlformats.org/presentationml/2006/main" xmlns:r="http://schemas.openxmlformats.org/officeDocument/2006/relationships">
+<p:sld xmlns:a="http://schemas.openxmlformats.org/drawingml/2006/main" xmlns:r="http://schemas.openxmlformats.org/officeDocument/2006/relationships" xmlns:p="http://schemas.openxmlformats.org/presentationml/2006/main">
   <p:cSld>
     <p:spTree>
       <p:nvGrpSpPr>
@@ -4439,7 +4532,14 @@
         <p:cNvGrpSpPr/>
         <p:nvPr/>
       </p:nvGrpSpPr>
-      <p:grpSpPr/>
+      <p:grpSpPr>
+        <a:xfrm>
+          <a:off x="0" y="0"/>
+          <a:ext cx="0" cy="0"/>
+          <a:chOff x="0" y="0"/>
+          <a:chExt cx="0" cy="0"/>
+        </a:xfrm>
+      </p:grpSpPr>
       <p:sp>
         <p:nvSpPr>
           <p:cNvPr id="2" name="TextBox 1"/>
@@ -4457,7 +4557,7 @@
           <a:noFill/>
         </p:spPr>
         <p:txBody>
-          <a:bodyPr wrap="square" lIns="0" rIns="0" tIns="0" bIns="0">
+          <a:bodyPr wrap="square" lIns="0" tIns="0" rIns="0" bIns="0">
             <a:spAutoFit/>
           </a:bodyPr>
           <a:lstStyle/>
@@ -4493,7 +4593,7 @@
           <a:noFill/>
         </p:spPr>
         <p:txBody>
-          <a:bodyPr wrap="square" lIns="0" rIns="0" tIns="0" bIns="0">
+          <a:bodyPr wrap="square" lIns="0" tIns="0" rIns="0" bIns="0">
             <a:spAutoFit/>
           </a:bodyPr>
           <a:lstStyle/>
@@ -4554,6 +4654,7 @@
           <a:lstStyle/>
           <a:p>
             <a:pPr algn="ctr"/>
+            <a:endParaRPr/>
           </a:p>
         </p:txBody>
       </p:sp>
@@ -4576,11 +4677,41 @@
                 <a:tableStyleId>{5C22544A-7EE6-4342-B048-85BDC9FD1C3A}</a:tableStyleId>
               </a:tblPr>
               <a:tblGrid>
-                <a:gridCol w="2011680"/>
-                <a:gridCol w="2377440"/>
-                <a:gridCol w="2194560"/>
-                <a:gridCol w="2103120"/>
-                <a:gridCol w="2039112"/>
+                <a:gridCol w="2011680">
+                  <a:extLst>
+                    <a:ext uri="{9D8B030D-6E8A-4147-A177-3AD203B41FA5}">
+                      <a16:colId xmlns:a16="http://schemas.microsoft.com/office/drawing/2014/main" val="20000"/>
+                    </a:ext>
+                  </a:extLst>
+                </a:gridCol>
+                <a:gridCol w="2377440">
+                  <a:extLst>
+                    <a:ext uri="{9D8B030D-6E8A-4147-A177-3AD203B41FA5}">
+                      <a16:colId xmlns:a16="http://schemas.microsoft.com/office/drawing/2014/main" val="20001"/>
+                    </a:ext>
+                  </a:extLst>
+                </a:gridCol>
+                <a:gridCol w="2194560">
+                  <a:extLst>
+                    <a:ext uri="{9D8B030D-6E8A-4147-A177-3AD203B41FA5}">
+                      <a16:colId xmlns:a16="http://schemas.microsoft.com/office/drawing/2014/main" val="20002"/>
+                    </a:ext>
+                  </a:extLst>
+                </a:gridCol>
+                <a:gridCol w="2103120">
+                  <a:extLst>
+                    <a:ext uri="{9D8B030D-6E8A-4147-A177-3AD203B41FA5}">
+                      <a16:colId xmlns:a16="http://schemas.microsoft.com/office/drawing/2014/main" val="20003"/>
+                    </a:ext>
+                  </a:extLst>
+                </a:gridCol>
+                <a:gridCol w="2039112">
+                  <a:extLst>
+                    <a:ext uri="{9D8B030D-6E8A-4147-A177-3AD203B41FA5}">
+                      <a16:colId xmlns:a16="http://schemas.microsoft.com/office/drawing/2014/main" val="20004"/>
+                    </a:ext>
+                  </a:extLst>
+                </a:gridCol>
               </a:tblGrid>
               <a:tr h="932688">
                 <a:tc>
@@ -4698,6 +4829,11 @@
                     </a:solidFill>
                   </a:tcPr>
                 </a:tc>
+                <a:extLst>
+                  <a:ext uri="{0D108BD9-81ED-4DB2-BD59-A6C34878D82A}">
+                    <a16:rowId xmlns:a16="http://schemas.microsoft.com/office/drawing/2014/main" val="10000"/>
+                  </a:ext>
+                </a:extLst>
               </a:tr>
               <a:tr h="932688">
                 <a:tc>
@@ -4819,6 +4955,11 @@
                     </a:solidFill>
                   </a:tcPr>
                 </a:tc>
+                <a:extLst>
+                  <a:ext uri="{0D108BD9-81ED-4DB2-BD59-A6C34878D82A}">
+                    <a16:rowId xmlns:a16="http://schemas.microsoft.com/office/drawing/2014/main" val="10001"/>
+                  </a:ext>
+                </a:extLst>
               </a:tr>
               <a:tr h="932688">
                 <a:tc>
@@ -4940,6 +5081,11 @@
                     </a:solidFill>
                   </a:tcPr>
                 </a:tc>
+                <a:extLst>
+                  <a:ext uri="{0D108BD9-81ED-4DB2-BD59-A6C34878D82A}">
+                    <a16:rowId xmlns:a16="http://schemas.microsoft.com/office/drawing/2014/main" val="10002"/>
+                  </a:ext>
+                </a:extLst>
               </a:tr>
               <a:tr h="932688">
                 <a:tc>
@@ -5061,6 +5207,11 @@
                     </a:solidFill>
                   </a:tcPr>
                 </a:tc>
+                <a:extLst>
+                  <a:ext uri="{0D108BD9-81ED-4DB2-BD59-A6C34878D82A}">
+                    <a16:rowId xmlns:a16="http://schemas.microsoft.com/office/drawing/2014/main" val="10003"/>
+                  </a:ext>
+                </a:extLst>
               </a:tr>
               <a:tr h="932688">
                 <a:tc>
@@ -5182,6 +5333,11 @@
                     </a:solidFill>
                   </a:tcPr>
                 </a:tc>
+                <a:extLst>
+                  <a:ext uri="{0D108BD9-81ED-4DB2-BD59-A6C34878D82A}">
+                    <a16:rowId xmlns:a16="http://schemas.microsoft.com/office/drawing/2014/main" val="10004"/>
+                  </a:ext>
+                </a:extLst>
               </a:tr>
             </a:tbl>
           </a:graphicData>
@@ -5196,7 +5352,7 @@
 </file>
 
 <file path=ppt/slides/slide5.xml><?xml version="1.0" encoding="utf-8"?>
-<p:sld xmlns:a="http://schemas.openxmlformats.org/drawingml/2006/main" xmlns:p="http://schemas.openxmlformats.org/presentationml/2006/main" xmlns:r="http://schemas.openxmlformats.org/officeDocument/2006/relationships">
+<p:sld xmlns:a="http://schemas.openxmlformats.org/drawingml/2006/main" xmlns:r="http://schemas.openxmlformats.org/officeDocument/2006/relationships" xmlns:p="http://schemas.openxmlformats.org/presentationml/2006/main">
   <p:cSld>
     <p:spTree>
       <p:nvGrpSpPr>
@@ -5204,7 +5360,14 @@
         <p:cNvGrpSpPr/>
         <p:nvPr/>
       </p:nvGrpSpPr>
-      <p:grpSpPr/>
+      <p:grpSpPr>
+        <a:xfrm>
+          <a:off x="0" y="0"/>
+          <a:ext cx="0" cy="0"/>
+          <a:chOff x="0" y="0"/>
+          <a:chExt cx="0" cy="0"/>
+        </a:xfrm>
+      </p:grpSpPr>
       <p:sp>
         <p:nvSpPr>
           <p:cNvPr id="2" name="TextBox 1"/>
@@ -5222,7 +5385,7 @@
           <a:noFill/>
         </p:spPr>
         <p:txBody>
-          <a:bodyPr wrap="square" lIns="0" rIns="0" tIns="0" bIns="0">
+          <a:bodyPr wrap="square" lIns="0" tIns="0" rIns="0" bIns="0">
             <a:spAutoFit/>
           </a:bodyPr>
           <a:lstStyle/>
@@ -5258,7 +5421,7 @@
           <a:noFill/>
         </p:spPr>
         <p:txBody>
-          <a:bodyPr wrap="square" lIns="0" rIns="0" tIns="0" bIns="0">
+          <a:bodyPr wrap="square" lIns="0" tIns="0" rIns="0" bIns="0">
             <a:spAutoFit/>
           </a:bodyPr>
           <a:lstStyle/>
@@ -5319,6 +5482,7 @@
           <a:lstStyle/>
           <a:p>
             <a:pPr algn="ctr"/>
+            <a:endParaRPr/>
           </a:p>
         </p:txBody>
       </p:sp>
@@ -5360,7 +5524,7 @@
           </a:fontRef>
         </p:style>
         <p:txBody>
-          <a:bodyPr rtlCol="0" anchor="ctr" wrap="square" lIns="274320" tIns="164592"/>
+          <a:bodyPr wrap="square" lIns="274320" tIns="164592" rtlCol="0" anchor="ctr"/>
           <a:lstStyle/>
           <a:p>
             <a:pPr algn="ctr">
@@ -5444,7 +5608,7 @@
           </a:fontRef>
         </p:style>
         <p:txBody>
-          <a:bodyPr rtlCol="0" anchor="ctr" wrap="square" lIns="274320" tIns="164592"/>
+          <a:bodyPr wrap="square" lIns="274320" tIns="164592" rtlCol="0" anchor="ctr"/>
           <a:lstStyle/>
           <a:p>
             <a:pPr algn="ctr">
@@ -5528,7 +5692,7 @@
           </a:fontRef>
         </p:style>
         <p:txBody>
-          <a:bodyPr rtlCol="0" anchor="ctr" wrap="square" lIns="274320" tIns="164592"/>
+          <a:bodyPr wrap="square" lIns="274320" tIns="164592" rtlCol="0" anchor="ctr"/>
           <a:lstStyle/>
           <a:p>
             <a:pPr algn="ctr">
@@ -5583,7 +5747,7 @@
 </file>
 
 <file path=ppt/slides/slide6.xml><?xml version="1.0" encoding="utf-8"?>
-<p:sld xmlns:a="http://schemas.openxmlformats.org/drawingml/2006/main" xmlns:p="http://schemas.openxmlformats.org/presentationml/2006/main" xmlns:r="http://schemas.openxmlformats.org/officeDocument/2006/relationships">
+<p:sld xmlns:a="http://schemas.openxmlformats.org/drawingml/2006/main" xmlns:r="http://schemas.openxmlformats.org/officeDocument/2006/relationships" xmlns:p="http://schemas.openxmlformats.org/presentationml/2006/main">
   <p:cSld>
     <p:spTree>
       <p:nvGrpSpPr>
@@ -5591,7 +5755,14 @@
         <p:cNvGrpSpPr/>
         <p:nvPr/>
       </p:nvGrpSpPr>
-      <p:grpSpPr/>
+      <p:grpSpPr>
+        <a:xfrm>
+          <a:off x="0" y="0"/>
+          <a:ext cx="0" cy="0"/>
+          <a:chOff x="0" y="0"/>
+          <a:chExt cx="0" cy="0"/>
+        </a:xfrm>
+      </p:grpSpPr>
       <p:sp>
         <p:nvSpPr>
           <p:cNvPr id="2" name="TextBox 1"/>
@@ -5609,7 +5780,7 @@
           <a:noFill/>
         </p:spPr>
         <p:txBody>
-          <a:bodyPr wrap="square" lIns="0" rIns="0" tIns="0" bIns="0">
+          <a:bodyPr wrap="square" lIns="0" tIns="0" rIns="0" bIns="0">
             <a:spAutoFit/>
           </a:bodyPr>
           <a:lstStyle/>
@@ -5645,7 +5816,7 @@
           <a:noFill/>
         </p:spPr>
         <p:txBody>
-          <a:bodyPr wrap="square" lIns="0" rIns="0" tIns="0" bIns="0">
+          <a:bodyPr wrap="square" lIns="0" tIns="0" rIns="0" bIns="0">
             <a:spAutoFit/>
           </a:bodyPr>
           <a:lstStyle/>
@@ -5706,6 +5877,7 @@
           <a:lstStyle/>
           <a:p>
             <a:pPr algn="ctr"/>
+            <a:endParaRPr/>
           </a:p>
         </p:txBody>
       </p:sp>
@@ -5747,7 +5919,7 @@
           </a:fontRef>
         </p:style>
         <p:txBody>
-          <a:bodyPr rtlCol="0" anchor="ctr" wrap="square" lIns="228600" rIns="228600" tIns="228600"/>
+          <a:bodyPr wrap="square" lIns="228600" tIns="228600" rIns="228600" rtlCol="0" anchor="ctr"/>
           <a:lstStyle/>
           <a:p>
             <a:pPr algn="ctr">
@@ -5901,13 +6073,6 @@
           </a:p>
           <a:p>
             <a:br/>
-            <a:pPr>
-              <a:defRPr sz="1050" b="1">
-                <a:solidFill>
-                  <a:srgbClr val="166534"/>
-                </a:solidFill>
-              </a:defRPr>
-            </a:pPr>
             <a:r>
               <a:t>Status: 100% Implemented &amp; Tested</a:t>
             </a:r>
@@ -5952,7 +6117,7 @@
           </a:fontRef>
         </p:style>
         <p:txBody>
-          <a:bodyPr rtlCol="0" anchor="ctr" wrap="square" lIns="228600" rIns="228600" tIns="228600"/>
+          <a:bodyPr wrap="square" lIns="228600" tIns="228600" rIns="228600" rtlCol="0" anchor="ctr"/>
           <a:lstStyle/>
           <a:p>
             <a:pPr algn="ctr">
@@ -6061,13 +6226,6 @@
           </a:p>
           <a:p>
             <a:br/>
-            <a:pPr>
-              <a:defRPr sz="1050" b="1">
-                <a:solidFill>
-                  <a:srgbClr val="475569"/>
-                </a:solidFill>
-              </a:defRPr>
-            </a:pPr>
             <a:r>
               <a:t>Status: Next Milestone</a:t>
             </a:r>
@@ -6112,7 +6270,7 @@
           </a:fontRef>
         </p:style>
         <p:txBody>
-          <a:bodyPr rtlCol="0" anchor="ctr" wrap="square" lIns="228600" rIns="228600" tIns="228600"/>
+          <a:bodyPr wrap="square" lIns="228600" tIns="228600" rIns="228600" rtlCol="0" anchor="ctr"/>
           <a:lstStyle/>
           <a:p>
             <a:pPr algn="ctr">
@@ -6221,13 +6379,6 @@
           </a:p>
           <a:p>
             <a:br/>
-            <a:pPr>
-              <a:defRPr sz="1050" b="1">
-                <a:solidFill>
-                  <a:srgbClr val="475569"/>
-                </a:solidFill>
-              </a:defRPr>
-            </a:pPr>
             <a:r>
               <a:t>Status: Future Scope</a:t>
             </a:r>
@@ -6243,7 +6394,7 @@
 </file>
 
 <file path=ppt/slides/slide7.xml><?xml version="1.0" encoding="utf-8"?>
-<p:sld xmlns:a="http://schemas.openxmlformats.org/drawingml/2006/main" xmlns:p="http://schemas.openxmlformats.org/presentationml/2006/main" xmlns:r="http://schemas.openxmlformats.org/officeDocument/2006/relationships">
+<p:sld xmlns:a="http://schemas.openxmlformats.org/drawingml/2006/main" xmlns:r="http://schemas.openxmlformats.org/officeDocument/2006/relationships" xmlns:p="http://schemas.openxmlformats.org/presentationml/2006/main">
   <p:cSld>
     <p:spTree>
       <p:nvGrpSpPr>
@@ -6251,7 +6402,14 @@
         <p:cNvGrpSpPr/>
         <p:nvPr/>
       </p:nvGrpSpPr>
-      <p:grpSpPr/>
+      <p:grpSpPr>
+        <a:xfrm>
+          <a:off x="0" y="0"/>
+          <a:ext cx="0" cy="0"/>
+          <a:chOff x="0" y="0"/>
+          <a:chExt cx="0" cy="0"/>
+        </a:xfrm>
+      </p:grpSpPr>
       <p:sp>
         <p:nvSpPr>
           <p:cNvPr id="2" name="TextBox 1"/>
@@ -6269,7 +6427,7 @@
           <a:noFill/>
         </p:spPr>
         <p:txBody>
-          <a:bodyPr wrap="square" lIns="0" rIns="0" tIns="0" bIns="0">
+          <a:bodyPr wrap="square" lIns="0" tIns="0" rIns="0" bIns="0">
             <a:spAutoFit/>
           </a:bodyPr>
           <a:lstStyle/>
@@ -6305,7 +6463,7 @@
           <a:noFill/>
         </p:spPr>
         <p:txBody>
-          <a:bodyPr wrap="square" lIns="0" rIns="0" tIns="0" bIns="0">
+          <a:bodyPr wrap="square" lIns="0" tIns="0" rIns="0" bIns="0">
             <a:spAutoFit/>
           </a:bodyPr>
           <a:lstStyle/>
@@ -6366,6 +6524,7 @@
           <a:lstStyle/>
           <a:p>
             <a:pPr algn="ctr"/>
+            <a:endParaRPr/>
           </a:p>
         </p:txBody>
       </p:sp>
@@ -6407,7 +6566,7 @@
           </a:fontRef>
         </p:style>
         <p:txBody>
-          <a:bodyPr rtlCol="0" anchor="ctr" wrap="square" lIns="228600" tIns="109728"/>
+          <a:bodyPr wrap="square" lIns="228600" tIns="109728" rtlCol="0" anchor="ctr"/>
           <a:lstStyle/>
           <a:p>
             <a:pPr algn="ctr">
@@ -6476,7 +6635,7 @@
           </a:fontRef>
         </p:style>
         <p:txBody>
-          <a:bodyPr rtlCol="0" anchor="ctr" wrap="square" lIns="228600" tIns="109728"/>
+          <a:bodyPr wrap="square" lIns="228600" tIns="109728" rtlCol="0" anchor="ctr"/>
           <a:lstStyle/>
           <a:p>
             <a:pPr algn="ctr">
@@ -6545,7 +6704,7 @@
           </a:fontRef>
         </p:style>
         <p:txBody>
-          <a:bodyPr rtlCol="0" anchor="ctr" wrap="square" lIns="228600" tIns="109728"/>
+          <a:bodyPr wrap="square" lIns="228600" tIns="109728" rtlCol="0" anchor="ctr"/>
           <a:lstStyle/>
           <a:p>
             <a:pPr algn="ctr">
@@ -6614,7 +6773,7 @@
           </a:fontRef>
         </p:style>
         <p:txBody>
-          <a:bodyPr rtlCol="0" anchor="ctr" wrap="square" lIns="228600" tIns="109728"/>
+          <a:bodyPr wrap="square" lIns="228600" tIns="109728" rtlCol="0" anchor="ctr"/>
           <a:lstStyle/>
           <a:p>
             <a:pPr algn="ctr">
@@ -6683,7 +6842,7 @@
           </a:fontRef>
         </p:style>
         <p:txBody>
-          <a:bodyPr rtlCol="0" anchor="ctr" wrap="square" lIns="274320" rIns="274320" tIns="274320"/>
+          <a:bodyPr wrap="square" lIns="274320" tIns="274320" rIns="274320" rtlCol="0" anchor="ctr"/>
           <a:lstStyle/>
           <a:p>
             <a:pPr algn="ctr">
@@ -6880,7 +7039,7 @@
 </file>
 
 <file path=ppt/slides/slide8.xml><?xml version="1.0" encoding="utf-8"?>
-<p:sld xmlns:a="http://schemas.openxmlformats.org/drawingml/2006/main" xmlns:p="http://schemas.openxmlformats.org/presentationml/2006/main" xmlns:r="http://schemas.openxmlformats.org/officeDocument/2006/relationships">
+<p:sld xmlns:a="http://schemas.openxmlformats.org/drawingml/2006/main" xmlns:r="http://schemas.openxmlformats.org/officeDocument/2006/relationships" xmlns:p="http://schemas.openxmlformats.org/presentationml/2006/main">
   <p:cSld>
     <p:spTree>
       <p:nvGrpSpPr>
@@ -6888,7 +7047,14 @@
         <p:cNvGrpSpPr/>
         <p:nvPr/>
       </p:nvGrpSpPr>
-      <p:grpSpPr/>
+      <p:grpSpPr>
+        <a:xfrm>
+          <a:off x="0" y="0"/>
+          <a:ext cx="0" cy="0"/>
+          <a:chOff x="0" y="0"/>
+          <a:chExt cx="0" cy="0"/>
+        </a:xfrm>
+      </p:grpSpPr>
       <p:sp>
         <p:nvSpPr>
           <p:cNvPr id="2" name="TextBox 1"/>
@@ -6906,7 +7072,7 @@
           <a:noFill/>
         </p:spPr>
         <p:txBody>
-          <a:bodyPr wrap="square" lIns="0" rIns="0" tIns="0" bIns="0">
+          <a:bodyPr wrap="square" lIns="0" tIns="0" rIns="0" bIns="0">
             <a:spAutoFit/>
           </a:bodyPr>
           <a:lstStyle/>
@@ -6942,7 +7108,7 @@
           <a:noFill/>
         </p:spPr>
         <p:txBody>
-          <a:bodyPr wrap="square" lIns="0" rIns="0" tIns="0" bIns="0">
+          <a:bodyPr wrap="square" lIns="0" tIns="0" rIns="0" bIns="0">
             <a:spAutoFit/>
           </a:bodyPr>
           <a:lstStyle/>
@@ -7003,6 +7169,7 @@
           <a:lstStyle/>
           <a:p>
             <a:pPr algn="ctr"/>
+            <a:endParaRPr/>
           </a:p>
         </p:txBody>
       </p:sp>
@@ -7044,7 +7211,7 @@
           </a:fontRef>
         </p:style>
         <p:txBody>
-          <a:bodyPr rtlCol="0" anchor="ctr" wrap="square" lIns="182880" rIns="182880" tIns="137160"/>
+          <a:bodyPr wrap="square" lIns="182880" tIns="137160" rIns="182880" rtlCol="0" anchor="ctr"/>
           <a:lstStyle/>
           <a:p>
             <a:pPr algn="ctr">
@@ -7125,7 +7292,7 @@
           </a:fontRef>
         </p:style>
         <p:txBody>
-          <a:bodyPr rtlCol="0" anchor="ctr" wrap="square" lIns="182880" rIns="182880" tIns="137160"/>
+          <a:bodyPr wrap="square" lIns="182880" tIns="137160" rIns="182880" rtlCol="0" anchor="ctr"/>
           <a:lstStyle/>
           <a:p>
             <a:pPr algn="ctr">
@@ -7206,7 +7373,7 @@
           </a:fontRef>
         </p:style>
         <p:txBody>
-          <a:bodyPr rtlCol="0" anchor="ctr" wrap="square" lIns="182880" rIns="182880" tIns="137160"/>
+          <a:bodyPr wrap="square" lIns="182880" tIns="137160" rIns="182880" rtlCol="0" anchor="ctr"/>
           <a:lstStyle/>
           <a:p>
             <a:pPr algn="ctr">
@@ -7287,7 +7454,7 @@
           </a:fontRef>
         </p:style>
         <p:txBody>
-          <a:bodyPr rtlCol="0" anchor="ctr" wrap="square" lIns="182880" rIns="182880" tIns="137160"/>
+          <a:bodyPr wrap="square" lIns="182880" tIns="137160" rIns="182880" rtlCol="0" anchor="ctr"/>
           <a:lstStyle/>
           <a:p>
             <a:pPr algn="ctr">
@@ -7368,7 +7535,7 @@
           </a:fontRef>
         </p:style>
         <p:txBody>
-          <a:bodyPr rtlCol="0" anchor="ctr" wrap="square" lIns="274320" rIns="274320" tIns="228600"/>
+          <a:bodyPr wrap="square" lIns="274320" tIns="228600" rIns="274320" rtlCol="0" anchor="ctr"/>
           <a:lstStyle/>
           <a:p>
             <a:pPr algn="ctr">
@@ -7560,7 +7727,7 @@
           </a:fontRef>
         </p:style>
         <p:txBody>
-          <a:bodyPr rtlCol="0" anchor="ctr" wrap="square" lIns="274320" rIns="274320" tIns="228600"/>
+          <a:bodyPr wrap="square" lIns="274320" tIns="228600" rIns="274320" rtlCol="0" anchor="ctr"/>
           <a:lstStyle/>
           <a:p>
             <a:pPr algn="ctr">

</xml_diff>